<commit_message>
Regenerate M10 artifacts with approved SAY
Co-authored-by: shaseaver25 <shannon@tailoredu.org>
</commit_message>
<xml_diff>
--- a/teaching-pack/14-M10-deterioration-v-noise/M10-instructor-reveal.pptx
+++ b/teaching-pack/14-M10-deterioration-v-noise/M10-instructor-reveal.pptx
@@ -510,18 +510,13 @@
           <a:lstStyle/>
           <a:p>
             <a:r>
-              <a:t>OLI SAY PLACEHOLDER — CLOUD PASS PENDING.</a:t>
+              <a:t>OLI CANON SAY — Cloud hard-review PASS · revised M10.</a:t>
             </a:r>
           </a:p>
           <a:p/>
           <a:p>
             <a:r>
-              <a:t>Beat: reveal title</a:t>
-            </a:r>
-          </a:p>
-          <a:p>
-            <a:r>
-              <a:t>Do not improvise or treat this scaffold as approved canon. Replace only from the Cloud-PASS M10 SAY file on follow-up.</a:t>
+              <a:t>REVEAL — Open only after students complete the paired hunt. SAY: “The designed error is not the arithmetic alone; it is what FOREMAN claims the arithmetic proves.”</a:t>
             </a:r>
           </a:p>
         </p:txBody>
@@ -591,18 +586,13 @@
           <a:lstStyle/>
           <a:p>
             <a:r>
-              <a:t>OLI SAY PLACEHOLDER — CLOUD PASS PENDING.</a:t>
+              <a:t>OLI CANON SAY — Cloud hard-review PASS · revised M10.</a:t>
             </a:r>
           </a:p>
           <a:p/>
           <a:p>
             <a:r>
-              <a:t>Beat: coupon result</a:t>
-            </a:r>
-          </a:p>
-          <a:p>
-            <a:r>
-              <a:t>Do not improvise or treat this scaffold as approved canon. Replace only from the Cloud-PASS M10 SAY file on follow-up.</a:t>
+              <a:t>REVEAL — SAY: “The coupon interval establishes the mechanics: sample mean, standard error, degrees of freedom, critical t, and interval.”</a:t>
             </a:r>
           </a:p>
         </p:txBody>
@@ -672,18 +662,13 @@
           <a:lstStyle/>
           <a:p>
             <a:r>
-              <a:t>OLI SAY PLACEHOLDER — CLOUD PASS PENDING.</a:t>
+              <a:t>OLI CANON SAY — Cloud hard-review PASS · revised M10.</a:t>
             </a:r>
           </a:p>
           <a:p/>
           <a:p>
             <a:r>
-              <a:t>Beat: paired estimate</a:t>
-            </a:r>
-          </a:p>
-          <a:p>
-            <a:r>
-              <a:t>Do not improvise or treat this scaffold as approved canon. Replace only from the Cloud-PASS M10 SAY file on follow-up.</a:t>
+              <a:t>REVEAL — SAY: “The eight paired differences have a mean of 6.0 microstrain. Same-location pairing and matched controls reduce noise, but the location changes still vary.”</a:t>
             </a:r>
           </a:p>
         </p:txBody>
@@ -753,18 +738,13 @@
           <a:lstStyle/>
           <a:p>
             <a:r>
-              <a:t>OLI SAY PLACEHOLDER — CLOUD PASS PENDING.</a:t>
+              <a:t>OLI CANON SAY — Cloud hard-review PASS · revised M10.</a:t>
             </a:r>
           </a:p>
           <a:p/>
           <a:p>
             <a:r>
-              <a:t>Beat: 95% interval</a:t>
-            </a:r>
-          </a:p>
-          <a:p>
-            <a:r>
-              <a:t>Do not improvise or treat this scaffold as approved canon. Replace only from the Cloud-PASS M10 SAY file on follow-up.</a:t>
+              <a:t>REVEAL — SAY: “The 95% interval just excludes zero. That supports evidence of a positive mean change at this confidence level—not a complete deterioration diagnosis.”</a:t>
             </a:r>
           </a:p>
         </p:txBody>
@@ -834,18 +814,13 @@
           <a:lstStyle/>
           <a:p>
             <a:r>
-              <a:t>OLI SAY PLACEHOLDER — CLOUD PASS PENDING.</a:t>
+              <a:t>OLI CANON SAY — Cloud hard-review PASS · revised M10.</a:t>
             </a:r>
           </a:p>
           <a:p/>
           <a:p>
             <a:r>
-              <a:t>Beat: 99% interval</a:t>
-            </a:r>
-          </a:p>
-          <a:p>
-            <a:r>
-              <a:t>Do not improvise or treat this scaffold as approved canon. Replace only from the Cloud-PASS M10 SAY file on follow-up.</a:t>
+              <a:t>REVEAL — SAY: “The 99% interval includes zero because the higher confidence demand widens the interval. The two intervals do not contradict each other.”</a:t>
             </a:r>
           </a:p>
         </p:txBody>
@@ -915,18 +890,13 @@
           <a:lstStyle/>
           <a:p>
             <a:r>
-              <a:t>OLI SAY PLACEHOLDER — CLOUD PASS PENDING.</a:t>
+              <a:t>OLI CANON SAY — Cloud hard-review PASS · revised M10.</a:t>
             </a:r>
           </a:p>
           <a:p/>
           <a:p>
             <a:r>
-              <a:t>Beat: confidence-level synthesis</a:t>
-            </a:r>
-          </a:p>
-          <a:p>
-            <a:r>
-              <a:t>Do not improvise or treat this scaffold as approved canon. Replace only from the Cloud-PASS M10 SAY file on follow-up.</a:t>
+              <a:t>REVEAL — SAY: “The honest synthesis is probably a small real change, with the confidence level stated. Borderline evidence is not no evidence, and it is not a slam-dunk.”</a:t>
             </a:r>
           </a:p>
         </p:txBody>
@@ -996,18 +966,13 @@
           <a:lstStyle/>
           <a:p>
             <a:r>
-              <a:t>OLI SAY PLACEHOLDER — CLOUD PASS PENDING.</a:t>
+              <a:t>OLI CANON SAY — Cloud hard-review PASS · revised M10.</a:t>
             </a:r>
           </a:p>
           <a:p/>
           <a:p>
             <a:r>
-              <a:t>Beat: FOREMAN designed error</a:t>
-            </a:r>
-          </a:p>
-          <a:p>
-            <a:r>
-              <a:t>Do not improvise or treat this scaffold as approved canon. Replace only from the Cloud-PASS M10 SAY file on follow-up.</a:t>
+              <a:t>REVEAL — SAY: “FOREMAN treats p = 0.04 as a 96% chance the claim is true and treats significant as confirmed and large. Both moves are wrong. You learned the opposite during Teach.”</a:t>
             </a:r>
           </a:p>
         </p:txBody>
@@ -1077,18 +1042,13 @@
           <a:lstStyle/>
           <a:p>
             <a:r>
-              <a:t>OLI SAY PLACEHOLDER — CLOUD PASS PENDING.</a:t>
+              <a:t>OLI CANON SAY — Cloud hard-review PASS · revised M10.</a:t>
             </a:r>
           </a:p>
           <a:p/>
           <a:p>
             <a:r>
-              <a:t>Beat: bounded response</a:t>
-            </a:r>
-          </a:p>
-          <a:p>
-            <a:r>
-              <a:t>Do not improvise or treat this scaffold as approved canon. Replace only from the Cloud-PASS M10 SAY file on follow-up.</a:t>
+              <a:t>REVEAL — SAY: “Tell Diane Halvorsen, PE: the matched locations show a small positive mean change; the 95% interval excludes zero, the 99% interval includes it, and these data alone do not confirm a damage mechanism.”</a:t>
             </a:r>
           </a:p>
         </p:txBody>
@@ -1158,18 +1118,13 @@
           <a:lstStyle/>
           <a:p>
             <a:r>
-              <a:t>OLI SAY PLACEHOLDER — CLOUD PASS PENDING.</a:t>
+              <a:t>OLI CANON SAY — Cloud hard-review PASS · revised M10.</a:t>
             </a:r>
           </a:p>
           <a:p/>
           <a:p>
             <a:r>
-              <a:t>Beat: HW5 and close</a:t>
-            </a:r>
-          </a:p>
-          <a:p>
-            <a:r>
-              <a:t>Do not improvise or treat this scaffold as approved canon. Replace only from the Cloud-PASS M10 SAY file on follow-up.</a:t>
+              <a:t>CLOSE — SAY: “HW5 is the interval on mean daily peak strain. HW3 callback: skipped duplicate-timestamp cleaning makes the apparent sample too large and the interval too narrow. Wes Tanaka, EIT’s quiet check remains continuity, not a co-solve. Eyes are coming to the Otter Bend record; no score or publish decision is named here.”</a:t>
             </a:r>
           </a:p>
         </p:txBody>

</xml_diff>